<commit_message>
anotehr lecture fix attempt 9999999
</commit_message>
<xml_diff>
--- a/docs/lectures/lecture_11/11_04_how_anova_is_dummy_var_regression.pptx
+++ b/docs/lectures/lecture_11/11_04_how_anova_is_dummy_var_regression.pptx
@@ -4197,7 +4197,7 @@
       </p:sp>
       <p:graphicFrame xmlns:a="http://schemas.openxmlformats.org/drawingml/2006/main" xmlns:r="http://schemas.openxmlformats.org/officeDocument/2006/relationships" xmlns:p="http://schemas.openxmlformats.org/presentationml/2006/main">
         <p:nvGraphicFramePr>
-          <p:cNvPr id="520066976" name=""/>
+          <p:cNvPr id="399120431" name=""/>
           <p:cNvGraphicFramePr>
             <a:graphicFrameLocks noGrp="true"/>
           </p:cNvGraphicFramePr>
@@ -4298,7 +4298,7 @@
       </p:sp>
       <p:graphicFrame xmlns:a="http://schemas.openxmlformats.org/drawingml/2006/main" xmlns:r="http://schemas.openxmlformats.org/officeDocument/2006/relationships" xmlns:p="http://schemas.openxmlformats.org/presentationml/2006/main">
         <p:nvGraphicFramePr>
-          <p:cNvPr id="900866917" name=""/>
+          <p:cNvPr id="741301419" name=""/>
           <p:cNvGraphicFramePr>
             <a:graphicFrameLocks noGrp="true"/>
           </p:cNvGraphicFramePr>
@@ -5181,7 +5181,7 @@
       </p:sp>
       <p:graphicFrame xmlns:a="http://schemas.openxmlformats.org/drawingml/2006/main" xmlns:r="http://schemas.openxmlformats.org/officeDocument/2006/relationships" xmlns:p="http://schemas.openxmlformats.org/presentationml/2006/main">
         <p:nvGraphicFramePr>
-          <p:cNvPr id="373563749" name=""/>
+          <p:cNvPr id="294399266" name=""/>
           <p:cNvGraphicFramePr>
             <a:graphicFrameLocks noGrp="true"/>
           </p:cNvGraphicFramePr>
@@ -6744,7 +6744,7 @@
       </p:sp>
       <p:graphicFrame xmlns:a="http://schemas.openxmlformats.org/drawingml/2006/main" xmlns:r="http://schemas.openxmlformats.org/officeDocument/2006/relationships" xmlns:p="http://schemas.openxmlformats.org/presentationml/2006/main">
         <p:nvGraphicFramePr>
-          <p:cNvPr id="292018743" name=""/>
+          <p:cNvPr id="813122048" name=""/>
           <p:cNvGraphicFramePr>
             <a:graphicFrameLocks noGrp="true"/>
           </p:cNvGraphicFramePr>

</xml_diff>

<commit_message>
will it work 2
</commit_message>
<xml_diff>
--- a/docs/lectures/lecture_11/11_04_how_anova_is_dummy_var_regression.pptx
+++ b/docs/lectures/lecture_11/11_04_how_anova_is_dummy_var_regression.pptx
@@ -4197,7 +4197,7 @@
       </p:sp>
       <p:graphicFrame xmlns:a="http://schemas.openxmlformats.org/drawingml/2006/main" xmlns:r="http://schemas.openxmlformats.org/officeDocument/2006/relationships" xmlns:p="http://schemas.openxmlformats.org/presentationml/2006/main">
         <p:nvGraphicFramePr>
-          <p:cNvPr id="850926219" name=""/>
+          <p:cNvPr id="594820816" name=""/>
           <p:cNvGraphicFramePr>
             <a:graphicFrameLocks noGrp="true"/>
           </p:cNvGraphicFramePr>
@@ -4298,7 +4298,7 @@
       </p:sp>
       <p:graphicFrame xmlns:a="http://schemas.openxmlformats.org/drawingml/2006/main" xmlns:r="http://schemas.openxmlformats.org/officeDocument/2006/relationships" xmlns:p="http://schemas.openxmlformats.org/presentationml/2006/main">
         <p:nvGraphicFramePr>
-          <p:cNvPr id="846179194" name=""/>
+          <p:cNvPr id="416212573" name=""/>
           <p:cNvGraphicFramePr>
             <a:graphicFrameLocks noGrp="true"/>
           </p:cNvGraphicFramePr>
@@ -5181,7 +5181,7 @@
       </p:sp>
       <p:graphicFrame xmlns:a="http://schemas.openxmlformats.org/drawingml/2006/main" xmlns:r="http://schemas.openxmlformats.org/officeDocument/2006/relationships" xmlns:p="http://schemas.openxmlformats.org/presentationml/2006/main">
         <p:nvGraphicFramePr>
-          <p:cNvPr id="539005948" name=""/>
+          <p:cNvPr id="638295088" name=""/>
           <p:cNvGraphicFramePr>
             <a:graphicFrameLocks noGrp="true"/>
           </p:cNvGraphicFramePr>
@@ -6744,7 +6744,7 @@
       </p:sp>
       <p:graphicFrame xmlns:a="http://schemas.openxmlformats.org/drawingml/2006/main" xmlns:r="http://schemas.openxmlformats.org/officeDocument/2006/relationships" xmlns:p="http://schemas.openxmlformats.org/presentationml/2006/main">
         <p:nvGraphicFramePr>
-          <p:cNvPr id="499802917" name=""/>
+          <p:cNvPr id="300984870" name=""/>
           <p:cNvGraphicFramePr>
             <a:graphicFrameLocks noGrp="true"/>
           </p:cNvGraphicFramePr>

</xml_diff>